<commit_message>
The role that prepares a unit's activities is "Technical Officer" (Técnico), not "Planner"; demo accounts tecnico.<code>@gdsc.tl; docs and deck follow
Co-Authored-By: Claude Sonnet 5.5 <noreply@anthropic.com>
</commit_message>
<xml_diff>
--- a/docs/Sistema-PAA-apresentacao-v5.pptx
+++ b/docs/Sistema-PAA-apresentacao-v5.pptx
@@ -128,26 +128,26 @@
   <p:extLst>
     <p:ext uri="{521415D9-36F7-43E2-AB2F-B90AF26B5E84}">
       <p14:sectionLst xmlns:p14="http://schemas.microsoft.com/office/powerpoint/2010/main">
-        <p14:section name="The plan" id="{135eb730-0567-c8cb-ebf5-e1d8f9a9e67c}">
+        <p14:section name="The plan" id="{f7881d82-e771-d009-9672-2baee1fc3e71}">
           <p14:sldIdLst>
             <p14:sldId id="256"/>
             <p14:sldId id="257"/>
             <p14:sldId id="258"/>
           </p14:sldIdLst>
         </p14:section>
-        <p14:section name="The year of the plan" id="{42c82ed5-279f-e903-380d-d40f3e14b482}">
+        <p14:section name="The year of the plan" id="{7dd66384-dfaf-d960-b472-0b947d8147ac}">
           <p14:sldIdLst>
             <p14:sldId id="259"/>
             <p14:sldId id="260"/>
           </p14:sldIdLst>
         </p14:section>
-        <p14:section name="Writing the plan" id="{6d9833ef-bb5d-4d44-2131-46d8e13ce928}">
+        <p14:section name="Writing the plan" id="{4b73b138-0d83-4930-4a1e-7dc601a517cd}">
           <p14:sldIdLst>
             <p14:sldId id="261"/>
             <p14:sldId id="262"/>
           </p14:sldIdLst>
         </p14:section>
-        <p14:section name="Approving the plan" id="{b85aa03d-e4ff-86e4-e89a-b74d006b0319}">
+        <p14:section name="Approving the plan" id="{f1bea7d9-1865-1215-5b7c-957cf5e74d95}">
           <p14:sldIdLst>
             <p14:sldId id="263"/>
             <p14:sldId id="264"/>
@@ -156,14 +156,14 @@
             <p14:sldId id="267"/>
           </p14:sldIdLst>
         </p14:section>
-        <p14:section name="Changing and carrying out the plan" id="{d1557759-3146-1557-b94a-ba9cc53245dd}">
+        <p14:section name="Changing and carrying out the plan" id="{ba74a230-9775-08ba-dcec-6a417c8a0d3e}">
           <p14:sldIdLst>
             <p14:sldId id="268"/>
             <p14:sldId id="269"/>
             <p14:sldId id="270"/>
           </p14:sldIdLst>
         </p14:section>
-        <p14:section name="Reporting and trust" id="{6566bcdf-0182-c559-3200-079e1a3dc756}">
+        <p14:section name="Reporting and trust" id="{ed6b6292-d55a-7d0e-5138-cbee62921b1a}">
           <p14:sldIdLst>
             <p14:sldId id="271"/>
             <p14:sldId id="272"/>
@@ -173,7 +173,7 @@
             <p14:sldId id="276"/>
           </p14:sldIdLst>
         </p14:section>
-        <p14:section name="Next" id="{56bb5ab1-c75a-0f86-7ff5-1a0cff3463fd}">
+        <p14:section name="Next" id="{682f1362-ddd5-4486-f04c-e5f660ee32a0}">
           <p14:sldIdLst>
             <p14:sldId id="277"/>
           </p14:sldIdLst>
@@ -1726,7 +1726,7 @@
           <a:p>
             <a:r>
               <a:rPr lang="en-US" dirty="0"/>
-              <a:t>An administrator loads the optional sample at Management, Sample Data: a ministry with its directorates, municipal directorates and autonomous bodies, each with its planner and its director. Purging removes only the sample.</a:t>
+              <a:t>An administrator loads the optional sample at Management, Sample Data: a ministry with its directorates, municipal directorates and autonomous bodies, each with its technical officer and its director. Purging removes only the sample.</a:t>
             </a:r>
             <a:endParaRPr lang="en-US" dirty="0"/>
           </a:p>
@@ -2254,7 +2254,7 @@
           <a:p>
             <a:r>
               <a:rPr lang="en-US" dirty="0"/>
-              <a:t>Every unit has its own people: a planner who prepares and a director who certifies. A unit sees its own activities and those of the units below it. Tabs separate drafts and returned work, activities in review, approved ones, and the ones that need my action. At the start of a year the previous year's plan can be copied as drafts, once.</a:t>
+              <a:t>Every unit has its own people: a technical officer who prepares and a director who certifies. A unit sees its own activities and those of the units below it. Tabs separate drafts and returned work, activities in review, approved ones, and the ones that need my action. At the start of a year the previous year's plan can be copied as drafts, once.</a:t>
             </a:r>
             <a:endParaRPr lang="en-US" dirty="0"/>
           </a:p>
@@ -7628,7 +7628,7 @@
       </p:sp>
       <p:pic>
         <p:nvPicPr>
-          <p:cNvPr id="21" name="Role icon 4" descr="Planner">    </p:cNvPr>
+          <p:cNvPr id="21" name="Role icon 4" descr="Technical officer">    </p:cNvPr>
           <p:cNvPicPr>
             <a:picLocks noChangeAspect="1"/>
           </p:cNvPicPr>
@@ -7683,7 +7683,7 @@
                 <a:ea typeface="Cambria" pitchFamily="34" charset="-122"/>
                 <a:cs typeface="Cambria" pitchFamily="34" charset="-120"/>
               </a:rPr>
-              <a:t>Planner</a:t>
+              <a:t>Technical officer</a:t>
             </a:r>
             <a:endParaRPr lang="en-US" sz="1700" dirty="0"/>
           </a:p>
@@ -11371,7 +11371,7 @@
                   <a:schemeClr val="tx1"/>
                 </a:solidFill>
               </a:rPr>
-              <a:t>The Ministry of Transport and Communications with its directorates, municipal directorates and autonomous bodies; the real State Budget plans for 2025 to 2027 and a planner and a director for every unit.</a:t>
+              <a:t>The Ministry of Transport and Communications with its directorates, municipal directorates and autonomous bodies; the real State Budget plans for 2025 to 2027 and a technical officer and a director for every unit.</a:t>
             </a:r>
             <a:endParaRPr lang="en-US" sz="1500" dirty="0"/>
           </a:p>
@@ -11512,7 +11512,7 @@
                   <a:schemeClr val="tx1"/>
                 </a:solidFill>
               </a:rPr>
-              <a:t>Sign in as a planner, a director and the head of a directorate and follow an activity from draft to approved, with the lists, interim cover and signing in order.</a:t>
+              <a:t>Sign in as a technical officer, a director and the head of a directorate and follow an activity from draft to approved, with the lists, interim cover and signing in order.</a:t>
             </a:r>
             <a:endParaRPr lang="en-US" sz="1500" dirty="0"/>
           </a:p>
@@ -11868,7 +11868,7 @@
                   <a:schemeClr val="bg1"/>
                 </a:solidFill>
               </a:rPr>
-              <a:t>Load the real structure and people, set the windows, and run one full plan with its own planners and director.</a:t>
+              <a:t>Load the real structure and people, set the windows, and run one full plan with its own technical officers and director.</a:t>
             </a:r>
             <a:endParaRPr lang="en-US" sz="2200" dirty="0"/>
           </a:p>
@@ -15323,7 +15323,7 @@
                   <a:schemeClr val="tx1"/>
                 </a:solidFill>
               </a:rPr>
-              <a:t>Each unit has a planner and a director; what a person sees and writes follows their unit.</a:t>
+              <a:t>Each unit has a technical officer and a director; what a person sees and writes follows their unit.</a:t>
             </a:r>
             <a:endParaRPr lang="en-US" sz="1800" dirty="0"/>
           </a:p>
@@ -15897,7 +15897,7 @@
                   <a:schemeClr val="accent3"/>
                 </a:solidFill>
               </a:rPr>
-              <a:t>Planner or director</a:t>
+              <a:t>Technical officer or director</a:t>
             </a:r>
             <a:endParaRPr lang="en-US" sz="1300" dirty="0"/>
           </a:p>

</xml_diff>